<commit_message>
chore: 提交 v3.1.2 修好的批次改善 pptx + v3.1.2 完成 handoff
技能包倉庫 v3.1.2 已推送並建立 tag(v3.1.1 tag 已刪除)。

本次更新:
- 重新產出 3 份改善 pptx(無旋轉、無疊加、無殘留)
- 新增 docs/handoff/2026-09-01-v312-final-fixes-handoff.md(完成記錄)
- 更新 docs/handoff/2026-08-31-batch-eval-rendering-issues-handoff.md(狀態改為 🟢 完成)
- 更新 batch_evaluation_summary.json(新批次結果)

對應技能包 commit 70fb30d(v3.1.2)

真實執行結果:
| 報告 | 原始 | v3.1.1 | v3.1.2 |
|------|------|--------|--------|
| 260811 | 5 張 | 13 張(含 3 張旋轉) | 16 張(無旋轉) |
| MS | 5 張 | 16 張(標題被覆蓋) | 19 張(標題清楚) |
| N160JCN | 9 張 | 18 張(疊加、殘留) | 21 張(獨立 slide) |

注意事項:
- v3.1.1 tag 已被刪除(因有未修問題),請勿使用
- v3.1.2 tag 為當前穩定版
</commit_message>
<xml_diff>
--- a/report/260811_Kobo_ZHT_RA6080_SPcomFailI_improved.pptx
+++ b/report/260811_Kobo_ZHT_RA6080_SPcomFailI_improved.pptx
@@ -24,6 +24,9 @@
     <p:sldId id="551" r:id="rId18"/>
     <p:sldId id="552" r:id="rId19"/>
     <p:sldId id="553" r:id="rId20"/>
+    <p:sldId id="554" r:id="rId21"/>
+    <p:sldId id="555" r:id="rId22"/>
+    <p:sldId id="556" r:id="rId23"/>
   </p:sldIdLst>
   <p:sldSz cx="9144000" cy="6858000" type="screen4x3"/>
   <p:notesSz cx="6797675" cy="9926638"/>
@@ -4523,17 +4526,22 @@
       <p:grpSpPr/>
       <p:sp>
         <p:nvSpPr>
-          <p:cNvPr id="2" name="Vertical Title 1"/>
-          <p:cNvSpPr>
-            <a:spLocks noGrp="1"/>
-          </p:cNvSpPr>
-          <p:nvPr>
-            <p:ph type="title" orient="vert"/>
-          </p:nvPr>
+          <p:cNvPr id="4" name="TextBox 3"/>
+          <p:cNvSpPr txBox="1"/>
+          <p:nvPr/>
         </p:nvSpPr>
-        <p:spPr/>
+        <p:spPr>
+          <a:xfrm>
+            <a:off x="457200" y="274320"/>
+            <a:ext cx="8229600" cy="914400"/>
+          </a:xfrm>
+          <a:prstGeom prst="rect">
+            <a:avLst/>
+          </a:prstGeom>
+          <a:noFill/>
+        </p:spPr>
         <p:txBody>
-          <a:bodyPr/>
+          <a:bodyPr wrap="square" lIns="45720" rIns="45720" tIns="18288" bIns="18288"/>
           <a:lstStyle/>
           <a:p>
             <a:r>
@@ -4544,17 +4552,22 @@
       </p:sp>
       <p:sp>
         <p:nvSpPr>
-          <p:cNvPr id="3" name="Vertical Text Placeholder 2"/>
-          <p:cNvSpPr>
-            <a:spLocks noGrp="1"/>
-          </p:cNvSpPr>
-          <p:nvPr>
-            <p:ph type="body" idx="1" orient="vert"/>
-          </p:nvPr>
+          <p:cNvPr id="5" name="TextBox 4"/>
+          <p:cNvSpPr txBox="1"/>
+          <p:nvPr/>
         </p:nvSpPr>
-        <p:spPr/>
+        <p:spPr>
+          <a:xfrm>
+            <a:off x="457200" y="1371600"/>
+            <a:ext cx="8229600" cy="5029200"/>
+          </a:xfrm>
+          <a:prstGeom prst="rect">
+            <a:avLst/>
+          </a:prstGeom>
+          <a:noFill/>
+        </p:spPr>
         <p:txBody>
-          <a:bodyPr/>
+          <a:bodyPr wrap="square" lIns="45720" rIns="45720" tIns="18288" bIns="18288"/>
           <a:lstStyle/>
           <a:p>
             <a:pPr>
@@ -4639,17 +4652,22 @@
       <p:grpSpPr/>
       <p:sp>
         <p:nvSpPr>
-          <p:cNvPr id="2" name="Vertical Title 1"/>
-          <p:cNvSpPr>
-            <a:spLocks noGrp="1"/>
-          </p:cNvSpPr>
-          <p:nvPr>
-            <p:ph type="title" orient="vert"/>
-          </p:nvPr>
+          <p:cNvPr id="4" name="TextBox 3"/>
+          <p:cNvSpPr txBox="1"/>
+          <p:nvPr/>
         </p:nvSpPr>
-        <p:spPr/>
+        <p:spPr>
+          <a:xfrm>
+            <a:off x="457200" y="274320"/>
+            <a:ext cx="8229600" cy="914400"/>
+          </a:xfrm>
+          <a:prstGeom prst="rect">
+            <a:avLst/>
+          </a:prstGeom>
+          <a:noFill/>
+        </p:spPr>
         <p:txBody>
-          <a:bodyPr/>
+          <a:bodyPr wrap="square" lIns="45720" rIns="45720" tIns="18288" bIns="18288"/>
           <a:lstStyle/>
           <a:p>
             <a:r>
@@ -4660,17 +4678,22 @@
       </p:sp>
       <p:sp>
         <p:nvSpPr>
-          <p:cNvPr id="3" name="Vertical Text Placeholder 2"/>
-          <p:cNvSpPr>
-            <a:spLocks noGrp="1"/>
-          </p:cNvSpPr>
-          <p:nvPr>
-            <p:ph type="body" idx="1" orient="vert"/>
-          </p:nvPr>
+          <p:cNvPr id="5" name="TextBox 4"/>
+          <p:cNvSpPr txBox="1"/>
+          <p:nvPr/>
         </p:nvSpPr>
-        <p:spPr/>
+        <p:spPr>
+          <a:xfrm>
+            <a:off x="457200" y="1371600"/>
+            <a:ext cx="8229600" cy="5029200"/>
+          </a:xfrm>
+          <a:prstGeom prst="rect">
+            <a:avLst/>
+          </a:prstGeom>
+          <a:noFill/>
+        </p:spPr>
         <p:txBody>
-          <a:bodyPr/>
+          <a:bodyPr wrap="square" lIns="45720" rIns="45720" tIns="18288" bIns="18288"/>
           <a:lstStyle/>
           <a:p>
             <a:pPr>
@@ -4745,7 +4768,7 @@
       </p:sp>
       <p:sp>
         <p:nvSpPr>
-          <p:cNvPr id="4" name="Rectangle 3"/>
+          <p:cNvPr id="6" name="Rectangle 5"/>
           <p:cNvSpPr/>
           <p:nvPr/>
         </p:nvSpPr>
@@ -4788,7 +4811,7 @@
       </p:sp>
       <p:sp>
         <p:nvSpPr>
-          <p:cNvPr id="5" name="Oval 4"/>
+          <p:cNvPr id="7" name="Oval 6"/>
           <p:cNvSpPr/>
           <p:nvPr/>
         </p:nvSpPr>
@@ -4841,7 +4864,7 @@
       </p:sp>
       <p:sp>
         <p:nvSpPr>
-          <p:cNvPr id="6" name="TextBox 5"/>
+          <p:cNvPr id="8" name="TextBox 7"/>
           <p:cNvSpPr txBox="1"/>
           <p:nvPr/>
         </p:nvSpPr>
@@ -4875,7 +4898,7 @@
       </p:sp>
       <p:sp>
         <p:nvSpPr>
-          <p:cNvPr id="7" name="TextBox 6"/>
+          <p:cNvPr id="9" name="TextBox 8"/>
           <p:cNvSpPr txBox="1"/>
           <p:nvPr/>
         </p:nvSpPr>
@@ -4909,7 +4932,7 @@
       </p:sp>
       <p:sp>
         <p:nvSpPr>
-          <p:cNvPr id="8" name="Oval 7"/>
+          <p:cNvPr id="10" name="Oval 9"/>
           <p:cNvSpPr/>
           <p:nvPr/>
         </p:nvSpPr>
@@ -4962,7 +4985,7 @@
       </p:sp>
       <p:sp>
         <p:nvSpPr>
-          <p:cNvPr id="9" name="TextBox 8"/>
+          <p:cNvPr id="11" name="TextBox 10"/>
           <p:cNvSpPr txBox="1"/>
           <p:nvPr/>
         </p:nvSpPr>
@@ -4996,7 +5019,7 @@
       </p:sp>
       <p:sp>
         <p:nvSpPr>
-          <p:cNvPr id="10" name="TextBox 9"/>
+          <p:cNvPr id="12" name="TextBox 11"/>
           <p:cNvSpPr txBox="1"/>
           <p:nvPr/>
         </p:nvSpPr>
@@ -5030,7 +5053,7 @@
       </p:sp>
       <p:sp>
         <p:nvSpPr>
-          <p:cNvPr id="11" name="Oval 10"/>
+          <p:cNvPr id="13" name="Oval 12"/>
           <p:cNvSpPr/>
           <p:nvPr/>
         </p:nvSpPr>
@@ -5083,7 +5106,7 @@
       </p:sp>
       <p:sp>
         <p:nvSpPr>
-          <p:cNvPr id="12" name="TextBox 11"/>
+          <p:cNvPr id="14" name="TextBox 13"/>
           <p:cNvSpPr txBox="1"/>
           <p:nvPr/>
         </p:nvSpPr>
@@ -5117,7 +5140,7 @@
       </p:sp>
       <p:sp>
         <p:nvSpPr>
-          <p:cNvPr id="13" name="TextBox 12"/>
+          <p:cNvPr id="15" name="TextBox 14"/>
           <p:cNvSpPr txBox="1"/>
           <p:nvPr/>
         </p:nvSpPr>
@@ -5169,45 +5192,33 @@
       <p:grpSpPr/>
       <p:sp>
         <p:nvSpPr>
-          <p:cNvPr id="2" name="Vertical Title 1"/>
-          <p:cNvSpPr>
-            <a:spLocks noGrp="1"/>
-          </p:cNvSpPr>
-          <p:nvPr>
-            <p:ph type="title" orient="vert"/>
-          </p:nvPr>
+          <p:cNvPr id="4" name="TextBox 3"/>
+          <p:cNvSpPr txBox="1"/>
+          <p:nvPr/>
         </p:nvSpPr>
-        <p:spPr/>
+        <p:spPr>
+          <a:xfrm>
+            <a:off x="457200" y="274320"/>
+            <a:ext cx="8229600" cy="914400"/>
+          </a:xfrm>
+          <a:prstGeom prst="rect">
+            <a:avLst/>
+          </a:prstGeom>
+          <a:noFill/>
+        </p:spPr>
         <p:txBody>
-          <a:bodyPr/>
+          <a:bodyPr wrap="square" lIns="45720" rIns="45720" tIns="18288" bIns="18288"/>
           <a:lstStyle/>
           <a:p>
             <a:r>
               <a:t>IQC 入料檢驗標準</a:t>
             </a:r>
           </a:p>
-        </p:txBody>
-      </p:sp>
-      <p:sp>
-        <p:nvSpPr>
-          <p:cNvPr id="3" name="Vertical Text Placeholder 2"/>
-          <p:cNvSpPr>
-            <a:spLocks noGrp="1"/>
-          </p:cNvSpPr>
-          <p:nvPr>
-            <p:ph type="body" idx="1" orient="vert"/>
-          </p:nvPr>
-        </p:nvSpPr>
-        <p:spPr/>
-        <p:txBody>
-          <a:bodyPr/>
-          <a:lstStyle/>
-          <a:p/>
         </p:txBody>
       </p:sp>
       <p:graphicFrame>
         <p:nvGraphicFramePr>
-          <p:cNvPr id="4" name="Table 3"/>
+          <p:cNvPr id="5" name="Table 4"/>
           <p:cNvGraphicFramePr>
             <a:graphicFrameLocks noGrp="1"/>
           </p:cNvGraphicFramePr>
@@ -5591,7 +5602,7 @@
       </p:graphicFrame>
       <p:sp>
         <p:nvSpPr>
-          <p:cNvPr id="5" name="TextBox 4"/>
+          <p:cNvPr id="6" name="TextBox 5"/>
           <p:cNvSpPr txBox="1"/>
           <p:nvPr/>
         </p:nvSpPr>
@@ -5644,45 +5655,33 @@
       <p:grpSpPr/>
       <p:sp>
         <p:nvSpPr>
-          <p:cNvPr id="2" name="Vertical Title 1"/>
-          <p:cNvSpPr>
-            <a:spLocks noGrp="1"/>
-          </p:cNvSpPr>
-          <p:nvPr>
-            <p:ph type="title" orient="vert"/>
-          </p:nvPr>
+          <p:cNvPr id="4" name="TextBox 3"/>
+          <p:cNvSpPr txBox="1"/>
+          <p:nvPr/>
         </p:nvSpPr>
-        <p:spPr/>
+        <p:spPr>
+          <a:xfrm>
+            <a:off x="457200" y="274320"/>
+            <a:ext cx="8229600" cy="914400"/>
+          </a:xfrm>
+          <a:prstGeom prst="rect">
+            <a:avLst/>
+          </a:prstGeom>
+          <a:noFill/>
+        </p:spPr>
         <p:txBody>
-          <a:bodyPr/>
+          <a:bodyPr wrap="square" lIns="45720" rIns="45720" tIns="18288" bIns="18288"/>
           <a:lstStyle/>
           <a:p>
             <a:r>
               <a:t>監測與知識管理 (KM)</a:t>
             </a:r>
           </a:p>
-        </p:txBody>
-      </p:sp>
-      <p:sp>
-        <p:nvSpPr>
-          <p:cNvPr id="3" name="Vertical Text Placeholder 2"/>
-          <p:cNvSpPr>
-            <a:spLocks noGrp="1"/>
-          </p:cNvSpPr>
-          <p:nvPr>
-            <p:ph type="body" idx="1" orient="vert"/>
-          </p:nvPr>
-        </p:nvSpPr>
-        <p:spPr/>
-        <p:txBody>
-          <a:bodyPr/>
-          <a:lstStyle/>
-          <a:p/>
         </p:txBody>
       </p:sp>
       <p:graphicFrame>
         <p:nvGraphicFramePr>
-          <p:cNvPr id="4" name="Table 3"/>
+          <p:cNvPr id="5" name="Table 4"/>
           <p:cNvGraphicFramePr>
             <a:graphicFrameLocks noGrp="1"/>
           </p:cNvGraphicFramePr>
@@ -6066,7 +6065,7 @@
       </p:graphicFrame>
       <p:sp>
         <p:nvSpPr>
-          <p:cNvPr id="5" name="TextBox 4"/>
+          <p:cNvPr id="6" name="TextBox 5"/>
           <p:cNvSpPr txBox="1"/>
           <p:nvPr/>
         </p:nvSpPr>
@@ -6099,16 +6098,274 @@
           </a:p>
         </p:txBody>
       </p:sp>
+    </p:spTree>
+  </p:cSld>
+  <p:clrMapOvr>
+    <a:masterClrMapping/>
+  </p:clrMapOvr>
+</p:sld>
+</file>
+
+<file path=ppt/slides/slide14.xml><?xml version="1.0" encoding="utf-8"?>
+<p:sld xmlns:a="http://schemas.openxmlformats.org/drawingml/2006/main" xmlns:p="http://schemas.openxmlformats.org/presentationml/2006/main" xmlns:r="http://schemas.openxmlformats.org/officeDocument/2006/relationships">
+  <p:cSld>
+    <p:spTree>
+      <p:nvGrpSpPr>
+        <p:cNvPr id="1" name=""/>
+        <p:cNvGrpSpPr/>
+        <p:nvPr/>
+      </p:nvGrpSpPr>
+      <p:grpSpPr/>
       <p:sp>
         <p:nvSpPr>
-          <p:cNvPr id="6" name="TextBox 5"/>
+          <p:cNvPr id="4" name="TextBox 3"/>
           <p:cNvSpPr txBox="1"/>
           <p:nvPr/>
         </p:nvSpPr>
         <p:spPr>
           <a:xfrm>
-            <a:off x="914400" y="4754880"/>
-            <a:ext cx="1371600" cy="259080"/>
+            <a:off x="457200" y="274320"/>
+            <a:ext cx="8229600" cy="914400"/>
+          </a:xfrm>
+          <a:prstGeom prst="rect">
+            <a:avLst/>
+          </a:prstGeom>
+          <a:noFill/>
+        </p:spPr>
+        <p:txBody>
+          <a:bodyPr wrap="square" lIns="45720" rIns="45720" tIns="18288" bIns="18288"/>
+          <a:lstStyle/>
+          <a:p>
+            <a:r>
+              <a:t>Executive Summary</a:t>
+            </a:r>
+          </a:p>
+        </p:txBody>
+      </p:sp>
+      <p:sp>
+        <p:nvSpPr>
+          <p:cNvPr id="5" name="TextBox 4"/>
+          <p:cNvSpPr txBox="1"/>
+          <p:nvPr/>
+        </p:nvSpPr>
+        <p:spPr>
+          <a:xfrm>
+            <a:off x="457200" y="1371600"/>
+            <a:ext cx="8229600" cy="5029200"/>
+          </a:xfrm>
+          <a:prstGeom prst="rect">
+            <a:avLst/>
+          </a:prstGeom>
+          <a:noFill/>
+        </p:spPr>
+        <p:txBody>
+          <a:bodyPr wrap="square" lIns="45720" rIns="45720" tIns="18288" bIns="18288"/>
+          <a:lstStyle/>
+          <a:p>
+            <a:pPr>
+              <a:defRPr sz="1400">
+                <a:solidFill>
+                  <a:srgbClr val="333333"/>
+                </a:solidFill>
+              </a:defRPr>
+            </a:pPr>
+            <a:r>
+              <a:t>本報告完成了初步的失效定位(Localization)，確認故障點位於Touch IC的INT/MISO引腳，但尚未達到正式FA報告的深度。報告最大的問題在於「僅有推測，缺乏根因」以及「完全沒有對策」。目前的結論僅能說「壞在哪裡」，無法說明「為什麼壞」以及「如何不再發生」。建議補足物理分析證據，並根據根因制定完整的改善與驗證計畫。</a:t>
+            </a:r>
+          </a:p>
+        </p:txBody>
+      </p:sp>
+    </p:spTree>
+  </p:cSld>
+  <p:clrMapOvr>
+    <a:masterClrMapping/>
+  </p:clrMapOvr>
+</p:sld>
+</file>
+
+<file path=ppt/slides/slide15.xml><?xml version="1.0" encoding="utf-8"?>
+<p:sld xmlns:a="http://schemas.openxmlformats.org/drawingml/2006/main" xmlns:p="http://schemas.openxmlformats.org/presentationml/2006/main" xmlns:r="http://schemas.openxmlformats.org/officeDocument/2006/relationships">
+  <p:cSld>
+    <p:spTree>
+      <p:nvGrpSpPr>
+        <p:cNvPr id="1" name=""/>
+        <p:cNvGrpSpPr/>
+        <p:nvPr/>
+      </p:nvGrpSpPr>
+      <p:grpSpPr/>
+      <p:sp>
+        <p:nvSpPr>
+          <p:cNvPr id="4" name="TextBox 3"/>
+          <p:cNvSpPr txBox="1"/>
+          <p:nvPr/>
+        </p:nvSpPr>
+        <p:spPr>
+          <a:xfrm>
+            <a:off x="457200" y="274320"/>
+            <a:ext cx="8229600" cy="914400"/>
+          </a:xfrm>
+          <a:prstGeom prst="rect">
+            <a:avLst/>
+          </a:prstGeom>
+          <a:noFill/>
+        </p:spPr>
+        <p:txBody>
+          <a:bodyPr wrap="square" lIns="45720" rIns="45720" tIns="18288" bIns="18288"/>
+          <a:lstStyle/>
+          <a:p>
+            <a:r>
+              <a:t>Key Improvements Required</a:t>
+            </a:r>
+          </a:p>
+        </p:txBody>
+      </p:sp>
+      <p:sp>
+        <p:nvSpPr>
+          <p:cNvPr id="5" name="TextBox 4"/>
+          <p:cNvSpPr txBox="1"/>
+          <p:nvPr/>
+        </p:nvSpPr>
+        <p:spPr>
+          <a:xfrm>
+            <a:off x="457200" y="1371600"/>
+            <a:ext cx="8229600" cy="5029200"/>
+          </a:xfrm>
+          <a:prstGeom prst="rect">
+            <a:avLst/>
+          </a:prstGeom>
+          <a:noFill/>
+        </p:spPr>
+        <p:txBody>
+          <a:bodyPr wrap="square" lIns="45720" rIns="45720" tIns="18288" bIns="18288"/>
+          <a:lstStyle/>
+          <a:p>
+            <a:pPr>
+              <a:defRPr sz="1300">
+                <a:solidFill>
+                  <a:srgbClr val="0070C0"/>
+                </a:solidFill>
+              </a:defRPr>
+            </a:pPr>
+            <a:r>
+              <a:t>• 提供了產品型號、日期與準備者，但缺乏具體的批號(Lot No.)、失效數量(Failure Quantity)以及明確的客戶名稱。</a:t>
+            </a:r>
+          </a:p>
+          <a:p>
+            <a:pPr>
+              <a:defRPr sz="1300">
+                <a:solidFill>
+                  <a:srgbClr val="0070C0"/>
+                </a:solidFill>
+              </a:defRPr>
+            </a:pPr>
+            <a:r>
+              <a:t>• 失效現象描述清楚(SPI無法通訊)，並提供了金手指對地的量測數據，但缺乏失效率(Failure Rate)的統計數據。</a:t>
+            </a:r>
+          </a:p>
+          <a:p>
+            <a:pPr>
+              <a:defRPr sz="1300">
+                <a:solidFill>
+                  <a:srgbClr val="FF0000"/>
+                </a:solidFill>
+              </a:defRPr>
+            </a:pPr>
+            <a:r>
+              <a:t>• 採用了排除法(移除TVS、移除IC)進行初步分析，邏輯尚屬合理，但缺乏更深層的物理分析(如SEM或X-ray)來確認IC內部的損傷機制。</a:t>
+            </a:r>
+          </a:p>
+          <a:p>
+            <a:pPr>
+              <a:defRPr sz="1300">
+                <a:solidFill>
+                  <a:srgbClr val="FF0000"/>
+                </a:solidFill>
+              </a:defRPr>
+            </a:pPr>
+            <a:r>
+              <a:t>• 提供了金手指量測表與電路圖，但圖片解析度較低，且缺乏對比組(Golden Sample)的量測數據來佐證異常。</a:t>
+            </a:r>
+          </a:p>
+          <a:p>
+            <a:pPr>
+              <a:defRPr sz="1300">
+                <a:solidFill>
+                  <a:srgbClr val="FF0000"/>
+                </a:solidFill>
+              </a:defRPr>
+            </a:pPr>
+            <a:r>
+              <a:t>• 結論僅停留在「推測」為I/O損傷，缺乏因果關係的深度分析。未說明為何會造成損傷(如ESD、過電壓或生產製程問題)，未應用5-Why分析。</a:t>
+            </a:r>
+          </a:p>
+          <a:p>
+            <a:pPr>
+              <a:defRPr sz="1300">
+                <a:solidFill>
+                  <a:srgbClr val="0070C0"/>
+                </a:solidFill>
+              </a:defRPr>
+            </a:pPr>
+            <a:r>
+              <a:t>• 報告中完全缺失改善對策、預防措施與驗證計畫。</a:t>
+            </a:r>
+          </a:p>
+        </p:txBody>
+      </p:sp>
+    </p:spTree>
+  </p:cSld>
+  <p:clrMapOvr>
+    <a:masterClrMapping/>
+  </p:clrMapOvr>
+</p:sld>
+</file>
+
+<file path=ppt/slides/slide16.xml><?xml version="1.0" encoding="utf-8"?>
+<p:sld xmlns:a="http://schemas.openxmlformats.org/drawingml/2006/main" xmlns:p="http://schemas.openxmlformats.org/presentationml/2006/main" xmlns:r="http://schemas.openxmlformats.org/officeDocument/2006/relationships">
+  <p:cSld>
+    <p:spTree>
+      <p:nvGrpSpPr>
+        <p:cNvPr id="1" name=""/>
+        <p:cNvGrpSpPr/>
+        <p:nvPr/>
+      </p:nvGrpSpPr>
+      <p:grpSpPr/>
+      <p:sp>
+        <p:nvSpPr>
+          <p:cNvPr id="4" name="TextBox 3"/>
+          <p:cNvSpPr txBox="1"/>
+          <p:nvPr/>
+        </p:nvSpPr>
+        <p:spPr>
+          <a:xfrm>
+            <a:off x="457200" y="274320"/>
+            <a:ext cx="8229600" cy="914400"/>
+          </a:xfrm>
+          <a:prstGeom prst="rect">
+            <a:avLst/>
+          </a:prstGeom>
+          <a:noFill/>
+        </p:spPr>
+        <p:txBody>
+          <a:bodyPr wrap="square" lIns="45720" rIns="45720" tIns="18288" bIns="18288"/>
+          <a:lstStyle/>
+          <a:p>
+            <a:r>
+              <a:t>6 維度評分分析</a:t>
+            </a:r>
+          </a:p>
+        </p:txBody>
+      </p:sp>
+      <p:sp>
+        <p:nvSpPr>
+          <p:cNvPr id="5" name="TextBox 4"/>
+          <p:cNvSpPr txBox="1"/>
+          <p:nvPr/>
+        </p:nvSpPr>
+        <p:spPr>
+          <a:xfrm>
+            <a:off x="914400" y="1645920"/>
+            <a:ext cx="1371600" cy="640080"/>
           </a:xfrm>
           <a:prstGeom prst="rect">
             <a:avLst/>
@@ -6130,14 +6387,14 @@
       </p:sp>
       <p:sp>
         <p:nvSpPr>
-          <p:cNvPr id="7" name="Rectangle 6"/>
+          <p:cNvPr id="6" name="Rectangle 5"/>
           <p:cNvSpPr/>
           <p:nvPr/>
         </p:nvSpPr>
         <p:spPr>
           <a:xfrm>
-            <a:off x="2286000" y="4800600"/>
-            <a:ext cx="6400800" cy="167640"/>
+            <a:off x="2286000" y="1691640"/>
+            <a:ext cx="6400800" cy="548640"/>
           </a:xfrm>
           <a:prstGeom prst="rect">
             <a:avLst/>
@@ -6173,14 +6430,14 @@
       </p:sp>
       <p:sp>
         <p:nvSpPr>
-          <p:cNvPr id="8" name="Rectangle 7"/>
+          <p:cNvPr id="7" name="Rectangle 6"/>
           <p:cNvSpPr/>
           <p:nvPr/>
         </p:nvSpPr>
         <p:spPr>
           <a:xfrm>
-            <a:off x="2286000" y="4800600"/>
-            <a:ext cx="4480560" cy="167640"/>
+            <a:off x="2286000" y="1691640"/>
+            <a:ext cx="4480560" cy="548640"/>
           </a:xfrm>
           <a:prstGeom prst="rect">
             <a:avLst/>
@@ -6216,14 +6473,14 @@
       </p:sp>
       <p:sp>
         <p:nvSpPr>
-          <p:cNvPr id="9" name="TextBox 8"/>
+          <p:cNvPr id="8" name="TextBox 7"/>
           <p:cNvSpPr txBox="1"/>
           <p:nvPr/>
         </p:nvSpPr>
         <p:spPr>
           <a:xfrm>
-            <a:off x="8732520" y="4754880"/>
-            <a:ext cx="411480" cy="259080"/>
+            <a:off x="8732520" y="1645920"/>
+            <a:ext cx="411480" cy="640080"/>
           </a:xfrm>
           <a:prstGeom prst="rect">
             <a:avLst/>
@@ -6249,14 +6506,14 @@
       </p:sp>
       <p:sp>
         <p:nvSpPr>
-          <p:cNvPr id="10" name="TextBox 9"/>
+          <p:cNvPr id="9" name="TextBox 8"/>
           <p:cNvSpPr txBox="1"/>
           <p:nvPr/>
         </p:nvSpPr>
         <p:spPr>
           <a:xfrm>
-            <a:off x="914400" y="5013960"/>
-            <a:ext cx="1371600" cy="259080"/>
+            <a:off x="914400" y="2286000"/>
+            <a:ext cx="1371600" cy="640080"/>
           </a:xfrm>
           <a:prstGeom prst="rect">
             <a:avLst/>
@@ -6278,14 +6535,14 @@
       </p:sp>
       <p:sp>
         <p:nvSpPr>
-          <p:cNvPr id="11" name="Rectangle 10"/>
+          <p:cNvPr id="10" name="Rectangle 9"/>
           <p:cNvSpPr/>
           <p:nvPr/>
         </p:nvSpPr>
         <p:spPr>
           <a:xfrm>
-            <a:off x="2286000" y="5059680"/>
-            <a:ext cx="6400800" cy="167640"/>
+            <a:off x="2286000" y="2331720"/>
+            <a:ext cx="6400800" cy="548640"/>
           </a:xfrm>
           <a:prstGeom prst="rect">
             <a:avLst/>
@@ -6321,14 +6578,14 @@
       </p:sp>
       <p:sp>
         <p:nvSpPr>
-          <p:cNvPr id="12" name="Rectangle 11"/>
+          <p:cNvPr id="11" name="Rectangle 10"/>
           <p:cNvSpPr/>
           <p:nvPr/>
         </p:nvSpPr>
         <p:spPr>
           <a:xfrm>
-            <a:off x="2286000" y="5059680"/>
-            <a:ext cx="4800600" cy="167640"/>
+            <a:off x="2286000" y="2331720"/>
+            <a:ext cx="4800600" cy="548640"/>
           </a:xfrm>
           <a:prstGeom prst="rect">
             <a:avLst/>
@@ -6364,14 +6621,14 @@
       </p:sp>
       <p:sp>
         <p:nvSpPr>
-          <p:cNvPr id="13" name="TextBox 12"/>
+          <p:cNvPr id="12" name="TextBox 11"/>
           <p:cNvSpPr txBox="1"/>
           <p:nvPr/>
         </p:nvSpPr>
         <p:spPr>
           <a:xfrm>
-            <a:off x="8732520" y="5013960"/>
-            <a:ext cx="411480" cy="259080"/>
+            <a:off x="8732520" y="2286000"/>
+            <a:ext cx="411480" cy="640080"/>
           </a:xfrm>
           <a:prstGeom prst="rect">
             <a:avLst/>
@@ -6397,14 +6654,14 @@
       </p:sp>
       <p:sp>
         <p:nvSpPr>
-          <p:cNvPr id="14" name="TextBox 13"/>
+          <p:cNvPr id="13" name="TextBox 12"/>
           <p:cNvSpPr txBox="1"/>
           <p:nvPr/>
         </p:nvSpPr>
         <p:spPr>
           <a:xfrm>
-            <a:off x="914400" y="5273040"/>
-            <a:ext cx="1371600" cy="259080"/>
+            <a:off x="914400" y="2926080"/>
+            <a:ext cx="1371600" cy="640080"/>
           </a:xfrm>
           <a:prstGeom prst="rect">
             <a:avLst/>
@@ -6426,14 +6683,14 @@
       </p:sp>
       <p:sp>
         <p:nvSpPr>
-          <p:cNvPr id="15" name="Rectangle 14"/>
+          <p:cNvPr id="14" name="Rectangle 13"/>
           <p:cNvSpPr/>
           <p:nvPr/>
         </p:nvSpPr>
         <p:spPr>
           <a:xfrm>
-            <a:off x="2286000" y="5318760"/>
-            <a:ext cx="6400800" cy="167640"/>
+            <a:off x="2286000" y="2971800"/>
+            <a:ext cx="6400800" cy="548640"/>
           </a:xfrm>
           <a:prstGeom prst="rect">
             <a:avLst/>
@@ -6469,14 +6726,14 @@
       </p:sp>
       <p:sp>
         <p:nvSpPr>
-          <p:cNvPr id="16" name="Rectangle 15"/>
+          <p:cNvPr id="15" name="Rectangle 14"/>
           <p:cNvSpPr/>
           <p:nvPr/>
         </p:nvSpPr>
         <p:spPr>
           <a:xfrm>
-            <a:off x="2286000" y="5318760"/>
-            <a:ext cx="4160520" cy="167640"/>
+            <a:off x="2286000" y="2971800"/>
+            <a:ext cx="4160520" cy="548640"/>
           </a:xfrm>
           <a:prstGeom prst="rect">
             <a:avLst/>
@@ -6512,14 +6769,14 @@
       </p:sp>
       <p:sp>
         <p:nvSpPr>
-          <p:cNvPr id="17" name="TextBox 16"/>
+          <p:cNvPr id="16" name="TextBox 15"/>
           <p:cNvSpPr txBox="1"/>
           <p:nvPr/>
         </p:nvSpPr>
         <p:spPr>
           <a:xfrm>
-            <a:off x="8732520" y="5273040"/>
-            <a:ext cx="411480" cy="259080"/>
+            <a:off x="8732520" y="2926080"/>
+            <a:ext cx="411480" cy="640080"/>
           </a:xfrm>
           <a:prstGeom prst="rect">
             <a:avLst/>
@@ -6545,14 +6802,14 @@
       </p:sp>
       <p:sp>
         <p:nvSpPr>
-          <p:cNvPr id="18" name="TextBox 17"/>
+          <p:cNvPr id="17" name="TextBox 16"/>
           <p:cNvSpPr txBox="1"/>
           <p:nvPr/>
         </p:nvSpPr>
         <p:spPr>
           <a:xfrm>
-            <a:off x="914400" y="5532120"/>
-            <a:ext cx="1371600" cy="259080"/>
+            <a:off x="914400" y="3566160"/>
+            <a:ext cx="1371600" cy="640080"/>
           </a:xfrm>
           <a:prstGeom prst="rect">
             <a:avLst/>
@@ -6574,14 +6831,14 @@
       </p:sp>
       <p:sp>
         <p:nvSpPr>
-          <p:cNvPr id="19" name="Rectangle 18"/>
+          <p:cNvPr id="18" name="Rectangle 17"/>
           <p:cNvSpPr/>
           <p:nvPr/>
         </p:nvSpPr>
         <p:spPr>
           <a:xfrm>
-            <a:off x="2286000" y="5577840"/>
-            <a:ext cx="6400800" cy="167640"/>
+            <a:off x="2286000" y="3611880"/>
+            <a:ext cx="6400800" cy="548640"/>
           </a:xfrm>
           <a:prstGeom prst="rect">
             <a:avLst/>
@@ -6617,14 +6874,14 @@
       </p:sp>
       <p:sp>
         <p:nvSpPr>
-          <p:cNvPr id="20" name="Rectangle 19"/>
+          <p:cNvPr id="19" name="Rectangle 18"/>
           <p:cNvSpPr/>
           <p:nvPr/>
         </p:nvSpPr>
         <p:spPr>
           <a:xfrm>
-            <a:off x="2286000" y="5577840"/>
-            <a:ext cx="3840480" cy="167640"/>
+            <a:off x="2286000" y="3611880"/>
+            <a:ext cx="3840480" cy="548640"/>
           </a:xfrm>
           <a:prstGeom prst="rect">
             <a:avLst/>
@@ -6660,14 +6917,14 @@
       </p:sp>
       <p:sp>
         <p:nvSpPr>
-          <p:cNvPr id="21" name="TextBox 20"/>
+          <p:cNvPr id="20" name="TextBox 19"/>
           <p:cNvSpPr txBox="1"/>
           <p:nvPr/>
         </p:nvSpPr>
         <p:spPr>
           <a:xfrm>
-            <a:off x="8732520" y="5532120"/>
-            <a:ext cx="411480" cy="259080"/>
+            <a:off x="8732520" y="3566160"/>
+            <a:ext cx="411480" cy="640080"/>
           </a:xfrm>
           <a:prstGeom prst="rect">
             <a:avLst/>
@@ -6693,14 +6950,14 @@
       </p:sp>
       <p:sp>
         <p:nvSpPr>
-          <p:cNvPr id="22" name="TextBox 21"/>
+          <p:cNvPr id="21" name="TextBox 20"/>
           <p:cNvSpPr txBox="1"/>
           <p:nvPr/>
         </p:nvSpPr>
         <p:spPr>
           <a:xfrm>
-            <a:off x="914400" y="5791200"/>
-            <a:ext cx="1371600" cy="259080"/>
+            <a:off x="914400" y="4206240"/>
+            <a:ext cx="1371600" cy="640080"/>
           </a:xfrm>
           <a:prstGeom prst="rect">
             <a:avLst/>
@@ -6722,14 +6979,14 @@
       </p:sp>
       <p:sp>
         <p:nvSpPr>
-          <p:cNvPr id="23" name="Rectangle 22"/>
+          <p:cNvPr id="22" name="Rectangle 21"/>
           <p:cNvSpPr/>
           <p:nvPr/>
         </p:nvSpPr>
         <p:spPr>
           <a:xfrm>
-            <a:off x="2286000" y="5836920"/>
-            <a:ext cx="6400800" cy="167640"/>
+            <a:off x="2286000" y="4251960"/>
+            <a:ext cx="6400800" cy="548640"/>
           </a:xfrm>
           <a:prstGeom prst="rect">
             <a:avLst/>
@@ -6765,14 +7022,14 @@
       </p:sp>
       <p:sp>
         <p:nvSpPr>
-          <p:cNvPr id="24" name="Rectangle 23"/>
+          <p:cNvPr id="23" name="Rectangle 22"/>
           <p:cNvSpPr/>
           <p:nvPr/>
         </p:nvSpPr>
         <p:spPr>
           <a:xfrm>
-            <a:off x="2286000" y="5836920"/>
-            <a:ext cx="3200400" cy="167640"/>
+            <a:off x="2286000" y="4251960"/>
+            <a:ext cx="3200400" cy="548640"/>
           </a:xfrm>
           <a:prstGeom prst="rect">
             <a:avLst/>
@@ -6808,14 +7065,14 @@
       </p:sp>
       <p:sp>
         <p:nvSpPr>
-          <p:cNvPr id="25" name="TextBox 24"/>
+          <p:cNvPr id="24" name="TextBox 23"/>
           <p:cNvSpPr txBox="1"/>
           <p:nvPr/>
         </p:nvSpPr>
         <p:spPr>
           <a:xfrm>
-            <a:off x="8732520" y="5791200"/>
-            <a:ext cx="411480" cy="259080"/>
+            <a:off x="8732520" y="4206240"/>
+            <a:ext cx="411480" cy="640080"/>
           </a:xfrm>
           <a:prstGeom prst="rect">
             <a:avLst/>
@@ -6841,14 +7098,14 @@
       </p:sp>
       <p:sp>
         <p:nvSpPr>
-          <p:cNvPr id="26" name="TextBox 25"/>
+          <p:cNvPr id="25" name="TextBox 24"/>
           <p:cNvSpPr txBox="1"/>
           <p:nvPr/>
         </p:nvSpPr>
         <p:spPr>
           <a:xfrm>
-            <a:off x="914400" y="6050280"/>
-            <a:ext cx="1371600" cy="259080"/>
+            <a:off x="914400" y="4846320"/>
+            <a:ext cx="1371600" cy="640080"/>
           </a:xfrm>
           <a:prstGeom prst="rect">
             <a:avLst/>
@@ -6870,14 +7127,14 @@
       </p:sp>
       <p:sp>
         <p:nvSpPr>
-          <p:cNvPr id="27" name="Rectangle 26"/>
+          <p:cNvPr id="26" name="Rectangle 25"/>
           <p:cNvSpPr/>
           <p:nvPr/>
         </p:nvSpPr>
         <p:spPr>
           <a:xfrm>
-            <a:off x="2286000" y="6096000"/>
-            <a:ext cx="6400800" cy="167640"/>
+            <a:off x="2286000" y="4892040"/>
+            <a:ext cx="6400800" cy="548640"/>
           </a:xfrm>
           <a:prstGeom prst="rect">
             <a:avLst/>
@@ -6913,14 +7170,14 @@
       </p:sp>
       <p:sp>
         <p:nvSpPr>
-          <p:cNvPr id="28" name="Rectangle 27"/>
+          <p:cNvPr id="27" name="Rectangle 26"/>
           <p:cNvSpPr/>
           <p:nvPr/>
         </p:nvSpPr>
         <p:spPr>
           <a:xfrm>
-            <a:off x="2286000" y="6096000"/>
-            <a:ext cx="4480560" cy="167640"/>
+            <a:off x="2286000" y="4892040"/>
+            <a:ext cx="4480560" cy="548640"/>
           </a:xfrm>
           <a:prstGeom prst="rect">
             <a:avLst/>
@@ -6956,14 +7213,14 @@
       </p:sp>
       <p:sp>
         <p:nvSpPr>
-          <p:cNvPr id="29" name="TextBox 28"/>
+          <p:cNvPr id="28" name="TextBox 27"/>
           <p:cNvSpPr txBox="1"/>
           <p:nvPr/>
         </p:nvSpPr>
         <p:spPr>
           <a:xfrm>
-            <a:off x="8732520" y="6050280"/>
-            <a:ext cx="411480" cy="259080"/>
+            <a:off x="8732520" y="4846320"/>
+            <a:ext cx="411480" cy="640080"/>
           </a:xfrm>
           <a:prstGeom prst="rect">
             <a:avLst/>
@@ -6983,167 +7240,6 @@
                 </a:solidFill>
               </a:rPr>
               <a:t>70/100</a:t>
-            </a:r>
-          </a:p>
-        </p:txBody>
-      </p:sp>
-      <p:sp>
-        <p:nvSpPr>
-          <p:cNvPr id="30" name="TextBox 29"/>
-          <p:cNvSpPr txBox="1"/>
-          <p:nvPr/>
-        </p:nvSpPr>
-        <p:spPr>
-          <a:xfrm>
-            <a:off x="4983480" y="2743200"/>
-            <a:ext cx="3703320" cy="1371600"/>
-          </a:xfrm>
-          <a:prstGeom prst="rect">
-            <a:avLst/>
-          </a:prstGeom>
-          <a:noFill/>
-        </p:spPr>
-        <p:txBody>
-          <a:bodyPr wrap="square">
-            <a:spAutoFit/>
-          </a:bodyPr>
-          <a:lstStyle/>
-          <a:p>
-            <a:pPr>
-              <a:defRPr b="1" sz="1400">
-                <a:solidFill>
-                  <a:srgbClr val="0070C0"/>
-                </a:solidFill>
-              </a:defRPr>
-            </a:pPr>
-            <a:r>
-              <a:t>Executive Summary</a:t>
-            </a:r>
-          </a:p>
-          <a:p>
-            <a:pPr>
-              <a:defRPr sz="1100"/>
-            </a:pPr>
-            <a:r>
-              <a:t>本報告完成了初步的失效定位(Localization)，確認故障點位於Touch IC的INT/MISO引腳，但尚未達到正式FA報告的深度。報告最大的問題在於「僅有推測，缺乏根因」以及「完全沒有對策」。目前的結論僅能說「壞在哪裡」，無法說明「為什麼壞」以及「如何不再發生」。建議補足物理分析證據，並根據根因制定完整的改善與驗證計畫。</a:t>
-            </a:r>
-          </a:p>
-        </p:txBody>
-      </p:sp>
-      <p:sp>
-        <p:nvSpPr>
-          <p:cNvPr id="31" name="TextBox 30"/>
-          <p:cNvSpPr txBox="1"/>
-          <p:nvPr/>
-        </p:nvSpPr>
-        <p:spPr>
-          <a:xfrm>
-            <a:off x="4983480" y="4206240"/>
-            <a:ext cx="3703320" cy="1828800"/>
-          </a:xfrm>
-          <a:prstGeom prst="rect">
-            <a:avLst/>
-          </a:prstGeom>
-          <a:noFill/>
-        </p:spPr>
-        <p:txBody>
-          <a:bodyPr wrap="square">
-            <a:spAutoFit/>
-          </a:bodyPr>
-          <a:lstStyle/>
-          <a:p>
-            <a:pPr>
-              <a:defRPr b="1" sz="1400">
-                <a:solidFill>
-                  <a:srgbClr val="FF0000"/>
-                </a:solidFill>
-              </a:defRPr>
-            </a:pPr>
-            <a:r>
-              <a:t>Key Improvements Required</a:t>
-            </a:r>
-          </a:p>
-          <a:p>
-            <a:pPr>
-              <a:defRPr sz="1000"/>
-            </a:pPr>
-            <a:r>
-              <a:t>• 提供了產品型號、日期與準備者，但缺乏具體的批號(Lot No.)、失效數量(Failure Quantity)以及明確的客戶名稱。</a:t>
-            </a:r>
-          </a:p>
-          <a:p>
-            <a:pPr>
-              <a:defRPr sz="1000"/>
-            </a:pPr>
-            <a:r>
-              <a:t>• 失效現象描述清楚(SPI無法通訊)，並提供了金手指對地的量測數據，但缺乏失效率(Failure Rate)的統計數據。</a:t>
-            </a:r>
-          </a:p>
-          <a:p>
-            <a:pPr>
-              <a:defRPr sz="1000"/>
-            </a:pPr>
-            <a:r>
-              <a:t>• 採用了排除法(移除TVS、移除IC)進行初步分析，邏輯尚屬合理，但缺乏更深層的物理分析(如SEM或X-ray)來確認IC內部的損傷機制。</a:t>
-            </a:r>
-          </a:p>
-        </p:txBody>
-      </p:sp>
-      <p:sp>
-        <p:nvSpPr>
-          <p:cNvPr id="32" name="TextBox 31"/>
-          <p:cNvSpPr txBox="1"/>
-          <p:nvPr/>
-        </p:nvSpPr>
-        <p:spPr>
-          <a:xfrm>
-            <a:off x="1463040" y="4206240"/>
-            <a:ext cx="3291840" cy="1828800"/>
-          </a:xfrm>
-          <a:prstGeom prst="rect">
-            <a:avLst/>
-          </a:prstGeom>
-          <a:noFill/>
-        </p:spPr>
-        <p:txBody>
-          <a:bodyPr wrap="square">
-            <a:spAutoFit/>
-          </a:bodyPr>
-          <a:lstStyle/>
-          <a:p>
-            <a:pPr>
-              <a:defRPr b="1" sz="1400">
-                <a:solidFill>
-                  <a:srgbClr val="0070C0"/>
-                </a:solidFill>
-              </a:defRPr>
-            </a:pPr>
-            <a:r>
-              <a:t>分析優點與成功驗證</a:t>
-            </a:r>
-          </a:p>
-          <a:p>
-            <a:pPr>
-              <a:defRPr sz="1000"/>
-            </a:pPr>
-            <a:r>
-              <a:t>✓ 初步排查邏輯清晰，透過移除元件成功定位故障點在於IC單體。</a:t>
-            </a:r>
-          </a:p>
-          <a:p>
-            <a:pPr>
-              <a:defRPr sz="1000"/>
-            </a:pPr>
-            <a:r>
-              <a:t>✓ 提供了初步的電性量測數據(OL, 47Ω, 58Ω)作為證據。</a:t>
-            </a:r>
-          </a:p>
-          <a:p>
-            <a:pPr>
-              <a:defRPr sz="1000"/>
-            </a:pPr>
-            <a:r>
-              <a:t>✓ 包含了電路圖與實際組件照片，有助於理解失效位置。</a:t>
             </a:r>
           </a:p>
         </p:txBody>
@@ -13955,17 +14051,22 @@
       <p:grpSpPr/>
       <p:sp>
         <p:nvSpPr>
-          <p:cNvPr id="2" name="Vertical Title 1"/>
-          <p:cNvSpPr>
-            <a:spLocks noGrp="1"/>
-          </p:cNvSpPr>
-          <p:nvPr>
-            <p:ph type="title" orient="vert"/>
-          </p:nvPr>
+          <p:cNvPr id="4" name="TextBox 3"/>
+          <p:cNvSpPr txBox="1"/>
+          <p:nvPr/>
         </p:nvSpPr>
-        <p:spPr/>
+        <p:spPr>
+          <a:xfrm>
+            <a:off x="457200" y="274320"/>
+            <a:ext cx="8229600" cy="914400"/>
+          </a:xfrm>
+          <a:prstGeom prst="rect">
+            <a:avLst/>
+          </a:prstGeom>
+          <a:noFill/>
+        </p:spPr>
         <p:txBody>
-          <a:bodyPr/>
+          <a:bodyPr wrap="square" lIns="45720" rIns="45720" tIns="18288" bIns="18288"/>
           <a:lstStyle/>
           <a:p>
             <a:r>
@@ -13976,24 +14077,7 @@
       </p:sp>
       <p:sp>
         <p:nvSpPr>
-          <p:cNvPr id="3" name="Vertical Text Placeholder 2"/>
-          <p:cNvSpPr>
-            <a:spLocks noGrp="1"/>
-          </p:cNvSpPr>
-          <p:nvPr>
-            <p:ph type="body" idx="1" orient="vert"/>
-          </p:nvPr>
-        </p:nvSpPr>
-        <p:spPr/>
-        <p:txBody>
-          <a:bodyPr/>
-          <a:lstStyle/>
-          <a:p/>
-        </p:txBody>
-      </p:sp>
-      <p:sp>
-        <p:nvSpPr>
-          <p:cNvPr id="4" name="Rectangle 3"/>
+          <p:cNvPr id="5" name="Rectangle 4"/>
           <p:cNvSpPr/>
           <p:nvPr/>
         </p:nvSpPr>
@@ -14042,7 +14126,7 @@
       </p:sp>
       <p:sp>
         <p:nvSpPr>
-          <p:cNvPr id="5" name="TextBox 4"/>
+          <p:cNvPr id="6" name="TextBox 5"/>
           <p:cNvSpPr txBox="1"/>
           <p:nvPr/>
         </p:nvSpPr>
@@ -14075,7 +14159,7 @@
       </p:sp>
       <p:sp>
         <p:nvSpPr>
-          <p:cNvPr id="6" name="Rectangle 5"/>
+          <p:cNvPr id="7" name="Rectangle 6"/>
           <p:cNvSpPr/>
           <p:nvPr/>
         </p:nvSpPr>
@@ -14124,7 +14208,7 @@
       </p:sp>
       <p:sp>
         <p:nvSpPr>
-          <p:cNvPr id="7" name="TextBox 6"/>
+          <p:cNvPr id="8" name="TextBox 7"/>
           <p:cNvSpPr txBox="1"/>
           <p:nvPr/>
         </p:nvSpPr>
@@ -14157,7 +14241,7 @@
       </p:sp>
       <p:sp>
         <p:nvSpPr>
-          <p:cNvPr id="8" name="Rectangle 7"/>
+          <p:cNvPr id="9" name="Rectangle 8"/>
           <p:cNvSpPr/>
           <p:nvPr/>
         </p:nvSpPr>
@@ -14206,7 +14290,7 @@
       </p:sp>
       <p:sp>
         <p:nvSpPr>
-          <p:cNvPr id="9" name="TextBox 8"/>
+          <p:cNvPr id="10" name="TextBox 9"/>
           <p:cNvSpPr txBox="1"/>
           <p:nvPr/>
         </p:nvSpPr>
@@ -14239,7 +14323,7 @@
       </p:sp>
       <p:sp>
         <p:nvSpPr>
-          <p:cNvPr id="10" name="Rectangle 9"/>
+          <p:cNvPr id="11" name="Rectangle 10"/>
           <p:cNvSpPr/>
           <p:nvPr/>
         </p:nvSpPr>
@@ -14288,7 +14372,7 @@
       </p:sp>
       <p:sp>
         <p:nvSpPr>
-          <p:cNvPr id="11" name="TextBox 10"/>
+          <p:cNvPr id="12" name="TextBox 11"/>
           <p:cNvSpPr txBox="1"/>
           <p:nvPr/>
         </p:nvSpPr>
@@ -14321,7 +14405,7 @@
       </p:sp>
       <p:sp>
         <p:nvSpPr>
-          <p:cNvPr id="12" name="Rectangle 11"/>
+          <p:cNvPr id="13" name="Rectangle 12"/>
           <p:cNvSpPr/>
           <p:nvPr/>
         </p:nvSpPr>
@@ -14370,7 +14454,7 @@
       </p:sp>
       <p:sp>
         <p:nvSpPr>
-          <p:cNvPr id="13" name="TextBox 12"/>
+          <p:cNvPr id="14" name="TextBox 13"/>
           <p:cNvSpPr txBox="1"/>
           <p:nvPr/>
         </p:nvSpPr>
@@ -14403,7 +14487,7 @@
       </p:sp>
       <p:sp>
         <p:nvSpPr>
-          <p:cNvPr id="14" name="Rectangle 13"/>
+          <p:cNvPr id="15" name="Rectangle 14"/>
           <p:cNvSpPr/>
           <p:nvPr/>
         </p:nvSpPr>
@@ -14452,7 +14536,7 @@
       </p:sp>
       <p:sp>
         <p:nvSpPr>
-          <p:cNvPr id="15" name="TextBox 14"/>
+          <p:cNvPr id="16" name="TextBox 15"/>
           <p:cNvSpPr txBox="1"/>
           <p:nvPr/>
         </p:nvSpPr>
@@ -14485,7 +14569,7 @@
       </p:sp>
       <p:sp>
         <p:nvSpPr>
-          <p:cNvPr id="16" name="Rectangle 15"/>
+          <p:cNvPr id="17" name="Rectangle 16"/>
           <p:cNvSpPr/>
           <p:nvPr/>
         </p:nvSpPr>
@@ -14534,7 +14618,7 @@
       </p:sp>
       <p:sp>
         <p:nvSpPr>
-          <p:cNvPr id="17" name="TextBox 16"/>
+          <p:cNvPr id="18" name="TextBox 17"/>
           <p:cNvSpPr txBox="1"/>
           <p:nvPr/>
         </p:nvSpPr>
@@ -14567,7 +14651,7 @@
       </p:sp>
       <p:sp>
         <p:nvSpPr>
-          <p:cNvPr id="18" name="TextBox 17"/>
+          <p:cNvPr id="19" name="TextBox 18"/>
           <p:cNvSpPr txBox="1"/>
           <p:nvPr/>
         </p:nvSpPr>
@@ -14582,9 +14666,7 @@
           <a:noFill/>
         </p:spPr>
         <p:txBody>
-          <a:bodyPr wrap="square">
-            <a:spAutoFit/>
-          </a:bodyPr>
+          <a:bodyPr wrap="square" lIns="45720" rIns="45720" tIns="18288" bIns="18288"/>
           <a:lstStyle/>
           <a:p>
             <a:pPr>
@@ -14628,17 +14710,22 @@
       <p:grpSpPr/>
       <p:sp>
         <p:nvSpPr>
-          <p:cNvPr id="2" name="Vertical Title 1"/>
-          <p:cNvSpPr>
-            <a:spLocks noGrp="1"/>
-          </p:cNvSpPr>
-          <p:nvPr>
-            <p:ph type="title" orient="vert"/>
-          </p:nvPr>
+          <p:cNvPr id="4" name="TextBox 3"/>
+          <p:cNvSpPr txBox="1"/>
+          <p:nvPr/>
         </p:nvSpPr>
-        <p:spPr/>
+        <p:spPr>
+          <a:xfrm>
+            <a:off x="457200" y="274320"/>
+            <a:ext cx="8229600" cy="914400"/>
+          </a:xfrm>
+          <a:prstGeom prst="rect">
+            <a:avLst/>
+          </a:prstGeom>
+          <a:noFill/>
+        </p:spPr>
         <p:txBody>
-          <a:bodyPr/>
+          <a:bodyPr wrap="square" lIns="45720" rIns="45720" tIns="18288" bIns="18288"/>
           <a:lstStyle/>
           <a:p>
             <a:r>
@@ -14649,24 +14736,7 @@
       </p:sp>
       <p:sp>
         <p:nvSpPr>
-          <p:cNvPr id="3" name="Vertical Text Placeholder 2"/>
-          <p:cNvSpPr>
-            <a:spLocks noGrp="1"/>
-          </p:cNvSpPr>
-          <p:nvPr>
-            <p:ph type="body" idx="1" orient="vert"/>
-          </p:nvPr>
-        </p:nvSpPr>
-        <p:spPr/>
-        <p:txBody>
-          <a:bodyPr/>
-          <a:lstStyle/>
-          <a:p/>
-        </p:txBody>
-      </p:sp>
-      <p:sp>
-        <p:nvSpPr>
-          <p:cNvPr id="4" name="Rectangle 3"/>
+          <p:cNvPr id="5" name="Rectangle 4"/>
           <p:cNvSpPr/>
           <p:nvPr/>
         </p:nvSpPr>
@@ -14715,7 +14785,7 @@
       </p:sp>
       <p:sp>
         <p:nvSpPr>
-          <p:cNvPr id="5" name="TextBox 4"/>
+          <p:cNvPr id="6" name="TextBox 5"/>
           <p:cNvSpPr txBox="1"/>
           <p:nvPr/>
         </p:nvSpPr>
@@ -14748,7 +14818,7 @@
       </p:sp>
       <p:sp>
         <p:nvSpPr>
-          <p:cNvPr id="6" name="Rectangle 5"/>
+          <p:cNvPr id="7" name="Rectangle 6"/>
           <p:cNvSpPr/>
           <p:nvPr/>
         </p:nvSpPr>
@@ -14797,7 +14867,7 @@
       </p:sp>
       <p:sp>
         <p:nvSpPr>
-          <p:cNvPr id="7" name="TextBox 6"/>
+          <p:cNvPr id="8" name="TextBox 7"/>
           <p:cNvSpPr txBox="1"/>
           <p:nvPr/>
         </p:nvSpPr>
@@ -14830,7 +14900,7 @@
       </p:sp>
       <p:sp>
         <p:nvSpPr>
-          <p:cNvPr id="8" name="Rectangle 7"/>
+          <p:cNvPr id="9" name="Rectangle 8"/>
           <p:cNvSpPr/>
           <p:nvPr/>
         </p:nvSpPr>
@@ -14879,7 +14949,7 @@
       </p:sp>
       <p:sp>
         <p:nvSpPr>
-          <p:cNvPr id="9" name="TextBox 8"/>
+          <p:cNvPr id="10" name="TextBox 9"/>
           <p:cNvSpPr txBox="1"/>
           <p:nvPr/>
         </p:nvSpPr>
@@ -14912,7 +14982,7 @@
       </p:sp>
       <p:sp>
         <p:nvSpPr>
-          <p:cNvPr id="10" name="Rectangle 9"/>
+          <p:cNvPr id="11" name="Rectangle 10"/>
           <p:cNvSpPr/>
           <p:nvPr/>
         </p:nvSpPr>
@@ -14961,7 +15031,7 @@
       </p:sp>
       <p:sp>
         <p:nvSpPr>
-          <p:cNvPr id="11" name="TextBox 10"/>
+          <p:cNvPr id="12" name="TextBox 11"/>
           <p:cNvSpPr txBox="1"/>
           <p:nvPr/>
         </p:nvSpPr>
@@ -14994,7 +15064,7 @@
       </p:sp>
       <p:sp>
         <p:nvSpPr>
-          <p:cNvPr id="12" name="Rectangle 11"/>
+          <p:cNvPr id="13" name="Rectangle 12"/>
           <p:cNvSpPr/>
           <p:nvPr/>
         </p:nvSpPr>
@@ -15043,7 +15113,7 @@
       </p:sp>
       <p:sp>
         <p:nvSpPr>
-          <p:cNvPr id="13" name="TextBox 12"/>
+          <p:cNvPr id="14" name="TextBox 13"/>
           <p:cNvSpPr txBox="1"/>
           <p:nvPr/>
         </p:nvSpPr>
@@ -15076,7 +15146,7 @@
       </p:sp>
       <p:sp>
         <p:nvSpPr>
-          <p:cNvPr id="14" name="Rectangle 13"/>
+          <p:cNvPr id="15" name="Rectangle 14"/>
           <p:cNvSpPr/>
           <p:nvPr/>
         </p:nvSpPr>
@@ -15125,7 +15195,7 @@
       </p:sp>
       <p:sp>
         <p:nvSpPr>
-          <p:cNvPr id="15" name="TextBox 14"/>
+          <p:cNvPr id="16" name="TextBox 15"/>
           <p:cNvSpPr txBox="1"/>
           <p:nvPr/>
         </p:nvSpPr>
@@ -15158,7 +15228,7 @@
       </p:sp>
       <p:sp>
         <p:nvSpPr>
-          <p:cNvPr id="16" name="Rectangle 15"/>
+          <p:cNvPr id="17" name="Rectangle 16"/>
           <p:cNvSpPr/>
           <p:nvPr/>
         </p:nvSpPr>
@@ -15207,7 +15277,7 @@
       </p:sp>
       <p:sp>
         <p:nvSpPr>
-          <p:cNvPr id="17" name="TextBox 16"/>
+          <p:cNvPr id="18" name="TextBox 17"/>
           <p:cNvSpPr txBox="1"/>
           <p:nvPr/>
         </p:nvSpPr>
@@ -15240,7 +15310,7 @@
       </p:sp>
       <p:sp>
         <p:nvSpPr>
-          <p:cNvPr id="18" name="Rectangle 17"/>
+          <p:cNvPr id="19" name="Rectangle 18"/>
           <p:cNvSpPr/>
           <p:nvPr/>
         </p:nvSpPr>
@@ -15289,7 +15359,7 @@
       </p:sp>
       <p:sp>
         <p:nvSpPr>
-          <p:cNvPr id="19" name="TextBox 18"/>
+          <p:cNvPr id="20" name="TextBox 19"/>
           <p:cNvSpPr txBox="1"/>
           <p:nvPr/>
         </p:nvSpPr>
@@ -15322,7 +15392,7 @@
       </p:sp>
       <p:graphicFrame>
         <p:nvGraphicFramePr>
-          <p:cNvPr id="20" name="Table 19"/>
+          <p:cNvPr id="21" name="Table 20"/>
           <p:cNvGraphicFramePr>
             <a:graphicFrameLocks noGrp="1"/>
           </p:cNvGraphicFramePr>
@@ -15760,45 +15830,33 @@
       <p:grpSpPr/>
       <p:sp>
         <p:nvSpPr>
-          <p:cNvPr id="2" name="Vertical Title 1"/>
-          <p:cNvSpPr>
-            <a:spLocks noGrp="1"/>
-          </p:cNvSpPr>
-          <p:nvPr>
-            <p:ph type="title" orient="vert"/>
-          </p:nvPr>
+          <p:cNvPr id="4" name="TextBox 3"/>
+          <p:cNvSpPr txBox="1"/>
+          <p:nvPr/>
         </p:nvSpPr>
-        <p:spPr/>
+        <p:spPr>
+          <a:xfrm>
+            <a:off x="457200" y="274320"/>
+            <a:ext cx="8229600" cy="914400"/>
+          </a:xfrm>
+          <a:prstGeom prst="rect">
+            <a:avLst/>
+          </a:prstGeom>
+          <a:noFill/>
+        </p:spPr>
         <p:txBody>
-          <a:bodyPr/>
+          <a:bodyPr wrap="square" lIns="45720" rIns="45720" tIns="18288" bIns="18288"/>
           <a:lstStyle/>
           <a:p>
             <a:r>
               <a:t>數據與證據支持</a:t>
             </a:r>
           </a:p>
-        </p:txBody>
-      </p:sp>
-      <p:sp>
-        <p:nvSpPr>
-          <p:cNvPr id="3" name="Vertical Text Placeholder 2"/>
-          <p:cNvSpPr>
-            <a:spLocks noGrp="1"/>
-          </p:cNvSpPr>
-          <p:nvPr>
-            <p:ph type="body" idx="1" orient="vert"/>
-          </p:nvPr>
-        </p:nvSpPr>
-        <p:spPr/>
-        <p:txBody>
-          <a:bodyPr/>
-          <a:lstStyle/>
-          <a:p/>
         </p:txBody>
       </p:sp>
       <p:graphicFrame>
         <p:nvGraphicFramePr>
-          <p:cNvPr id="4" name="Table 3"/>
+          <p:cNvPr id="5" name="Table 4"/>
           <p:cNvGraphicFramePr>
             <a:graphicFrameLocks noGrp="1"/>
           </p:cNvGraphicFramePr>
@@ -16336,7 +16394,7 @@
       </p:graphicFrame>
       <p:sp>
         <p:nvSpPr>
-          <p:cNvPr id="5" name="Rectangle 4"/>
+          <p:cNvPr id="6" name="Rectangle 5"/>
           <p:cNvSpPr/>
           <p:nvPr/>
         </p:nvSpPr>
@@ -16385,7 +16443,7 @@
       </p:sp>
       <p:sp>
         <p:nvSpPr>
-          <p:cNvPr id="6" name="TextBox 5"/>
+          <p:cNvPr id="7" name="TextBox 6"/>
           <p:cNvSpPr txBox="1"/>
           <p:nvPr/>
         </p:nvSpPr>
@@ -16418,7 +16476,7 @@
       </p:sp>
       <p:sp>
         <p:nvSpPr>
-          <p:cNvPr id="7" name="Rectangle 6"/>
+          <p:cNvPr id="8" name="Rectangle 7"/>
           <p:cNvSpPr/>
           <p:nvPr/>
         </p:nvSpPr>
@@ -16467,7 +16525,7 @@
       </p:sp>
       <p:sp>
         <p:nvSpPr>
-          <p:cNvPr id="8" name="TextBox 7"/>
+          <p:cNvPr id="9" name="TextBox 8"/>
           <p:cNvSpPr txBox="1"/>
           <p:nvPr/>
         </p:nvSpPr>
@@ -16500,7 +16558,7 @@
       </p:sp>
       <p:sp>
         <p:nvSpPr>
-          <p:cNvPr id="9" name="Rectangle 8"/>
+          <p:cNvPr id="10" name="Rectangle 9"/>
           <p:cNvSpPr/>
           <p:nvPr/>
         </p:nvSpPr>
@@ -16549,7 +16607,7 @@
       </p:sp>
       <p:sp>
         <p:nvSpPr>
-          <p:cNvPr id="10" name="TextBox 9"/>
+          <p:cNvPr id="11" name="TextBox 10"/>
           <p:cNvSpPr txBox="1"/>
           <p:nvPr/>
         </p:nvSpPr>
@@ -16582,7 +16640,7 @@
       </p:sp>
       <p:sp>
         <p:nvSpPr>
-          <p:cNvPr id="11" name="Rectangle 10"/>
+          <p:cNvPr id="12" name="Rectangle 11"/>
           <p:cNvSpPr/>
           <p:nvPr/>
         </p:nvSpPr>
@@ -16631,7 +16689,7 @@
       </p:sp>
       <p:sp>
         <p:nvSpPr>
-          <p:cNvPr id="12" name="TextBox 11"/>
+          <p:cNvPr id="13" name="TextBox 12"/>
           <p:cNvSpPr txBox="1"/>
           <p:nvPr/>
         </p:nvSpPr>
@@ -16664,7 +16722,7 @@
       </p:sp>
       <p:sp>
         <p:nvSpPr>
-          <p:cNvPr id="13" name="Rectangle 12"/>
+          <p:cNvPr id="14" name="Rectangle 13"/>
           <p:cNvSpPr/>
           <p:nvPr/>
         </p:nvSpPr>
@@ -16713,7 +16771,7 @@
       </p:sp>
       <p:sp>
         <p:nvSpPr>
-          <p:cNvPr id="14" name="TextBox 13"/>
+          <p:cNvPr id="15" name="TextBox 14"/>
           <p:cNvSpPr txBox="1"/>
           <p:nvPr/>
         </p:nvSpPr>
@@ -16746,7 +16804,7 @@
       </p:sp>
       <p:sp>
         <p:nvSpPr>
-          <p:cNvPr id="15" name="Rectangle 14"/>
+          <p:cNvPr id="16" name="Rectangle 15"/>
           <p:cNvSpPr/>
           <p:nvPr/>
         </p:nvSpPr>
@@ -16795,7 +16853,7 @@
       </p:sp>
       <p:sp>
         <p:nvSpPr>
-          <p:cNvPr id="16" name="TextBox 15"/>
+          <p:cNvPr id="17" name="TextBox 16"/>
           <p:cNvSpPr txBox="1"/>
           <p:nvPr/>
         </p:nvSpPr>
@@ -16828,7 +16886,7 @@
       </p:sp>
       <p:sp>
         <p:nvSpPr>
-          <p:cNvPr id="17" name="Rectangle 16"/>
+          <p:cNvPr id="18" name="Rectangle 17"/>
           <p:cNvSpPr/>
           <p:nvPr/>
         </p:nvSpPr>
@@ -16877,7 +16935,7 @@
       </p:sp>
       <p:sp>
         <p:nvSpPr>
-          <p:cNvPr id="18" name="TextBox 17"/>
+          <p:cNvPr id="19" name="TextBox 18"/>
           <p:cNvSpPr txBox="1"/>
           <p:nvPr/>
         </p:nvSpPr>
@@ -16928,17 +16986,22 @@
       <p:grpSpPr/>
       <p:sp>
         <p:nvSpPr>
-          <p:cNvPr id="2" name="Vertical Title 1"/>
-          <p:cNvSpPr>
-            <a:spLocks noGrp="1"/>
-          </p:cNvSpPr>
-          <p:nvPr>
-            <p:ph type="title" orient="vert"/>
-          </p:nvPr>
+          <p:cNvPr id="4" name="TextBox 3"/>
+          <p:cNvSpPr txBox="1"/>
+          <p:nvPr/>
         </p:nvSpPr>
-        <p:spPr/>
+        <p:spPr>
+          <a:xfrm>
+            <a:off x="457200" y="274320"/>
+            <a:ext cx="8229600" cy="914400"/>
+          </a:xfrm>
+          <a:prstGeom prst="rect">
+            <a:avLst/>
+          </a:prstGeom>
+          <a:noFill/>
+        </p:spPr>
         <p:txBody>
-          <a:bodyPr/>
+          <a:bodyPr wrap="square" lIns="45720" rIns="45720" tIns="18288" bIns="18288"/>
           <a:lstStyle/>
           <a:p>
             <a:r>
@@ -16949,84 +17012,7 @@
       </p:sp>
       <p:sp>
         <p:nvSpPr>
-          <p:cNvPr id="3" name="Vertical Text Placeholder 2"/>
-          <p:cNvSpPr>
-            <a:spLocks noGrp="1"/>
-          </p:cNvSpPr>
-          <p:nvPr>
-            <p:ph type="body" idx="1" orient="vert"/>
-          </p:nvPr>
-        </p:nvSpPr>
-        <p:spPr/>
-        <p:txBody>
-          <a:bodyPr/>
-          <a:lstStyle/>
-          <a:p>
-            <a:pPr>
-              <a:defRPr b="1" sz="1800">
-                <a:solidFill>
-                  <a:srgbClr val="0070C0"/>
-                </a:solidFill>
-              </a:defRPr>
-            </a:pPr>
-            <a:r>
-              <a:t>為什麼需要 5-Why:</a:t>
-            </a:r>
-          </a:p>
-          <a:p>
-            <a:pPr>
-              <a:defRPr sz="1400"/>
-            </a:pPr>
-            <a:r>
-              <a:t>採用了排除法(移除TVS、移除IC)進行初步分析，邏輯尚屬合理，但缺乏更深層的物理分析(如SEM或X-ray)來確認IC內部的損傷機制。</a:t>
-            </a:r>
-          </a:p>
-          <a:p>
-            <a:pPr>
-              <a:defRPr sz="1400"/>
-            </a:pPr>
-            <a:r>
-              <a:t>結論僅停留在「推測」為I/O損傷，缺乏因果關係的深度分析。未說明為何會造成損傷(如ESD、過電壓或生產製程問題)，未應用5-Why分析。</a:t>
-            </a:r>
-          </a:p>
-          <a:p>
-            <a:br/>
-            <a:pPr>
-              <a:defRPr b="1"/>
-            </a:pPr>
-            <a:r>
-              <a:t>[推導流程]</a:t>
-            </a:r>
-          </a:p>
-          <a:p>
-            <a:pPr>
-              <a:defRPr sz="1200"/>
-            </a:pPr>
-            <a:r>
-              <a:t>• 設定 DVT 正常品 vs PVT 異常品之對照組</a:t>
-            </a:r>
-          </a:p>
-          <a:p>
-            <a:pPr>
-              <a:defRPr sz="1200"/>
-            </a:pPr>
-            <a:r>
-              <a:t>• 使用獨立樣本 t 檢定驗證參數顯著性 (p &lt; 0.05)</a:t>
-            </a:r>
-          </a:p>
-          <a:p>
-            <a:pPr>
-              <a:defRPr sz="1200"/>
-            </a:pPr>
-            <a:r>
-              <a:t>• 確保統計證據支持最終提到的根本原因</a:t>
-            </a:r>
-          </a:p>
-        </p:txBody>
-      </p:sp>
-      <p:sp>
-        <p:nvSpPr>
-          <p:cNvPr id="4" name="Rounded Rectangle 3"/>
+          <p:cNvPr id="5" name="Rounded Rectangle 4"/>
           <p:cNvSpPr/>
           <p:nvPr/>
         </p:nvSpPr>
@@ -17079,7 +17065,7 @@
       </p:sp>
       <p:sp>
         <p:nvSpPr>
-          <p:cNvPr id="5" name="Right Arrow 4"/>
+          <p:cNvPr id="6" name="Right Arrow 5"/>
           <p:cNvSpPr/>
           <p:nvPr/>
         </p:nvSpPr>
@@ -17122,7 +17108,7 @@
       </p:sp>
       <p:sp>
         <p:nvSpPr>
-          <p:cNvPr id="6" name="Rounded Rectangle 5"/>
+          <p:cNvPr id="7" name="Rounded Rectangle 6"/>
           <p:cNvSpPr/>
           <p:nvPr/>
         </p:nvSpPr>
@@ -17175,7 +17161,7 @@
       </p:sp>
       <p:sp>
         <p:nvSpPr>
-          <p:cNvPr id="7" name="Right Arrow 6"/>
+          <p:cNvPr id="8" name="Right Arrow 7"/>
           <p:cNvSpPr/>
           <p:nvPr/>
         </p:nvSpPr>
@@ -17218,7 +17204,7 @@
       </p:sp>
       <p:sp>
         <p:nvSpPr>
-          <p:cNvPr id="8" name="Rounded Rectangle 7"/>
+          <p:cNvPr id="9" name="Rounded Rectangle 8"/>
           <p:cNvSpPr/>
           <p:nvPr/>
         </p:nvSpPr>
@@ -17271,7 +17257,7 @@
       </p:sp>
       <p:sp>
         <p:nvSpPr>
-          <p:cNvPr id="9" name="Right Arrow 8"/>
+          <p:cNvPr id="10" name="Right Arrow 9"/>
           <p:cNvSpPr/>
           <p:nvPr/>
         </p:nvSpPr>
@@ -17314,7 +17300,7 @@
       </p:sp>
       <p:sp>
         <p:nvSpPr>
-          <p:cNvPr id="10" name="Rounded Rectangle 9"/>
+          <p:cNvPr id="11" name="Rounded Rectangle 10"/>
           <p:cNvSpPr/>
           <p:nvPr/>
         </p:nvSpPr>
@@ -17367,7 +17353,7 @@
       </p:sp>
       <p:sp>
         <p:nvSpPr>
-          <p:cNvPr id="11" name="Right Arrow 10"/>
+          <p:cNvPr id="12" name="Right Arrow 11"/>
           <p:cNvSpPr/>
           <p:nvPr/>
         </p:nvSpPr>
@@ -17410,7 +17396,7 @@
       </p:sp>
       <p:sp>
         <p:nvSpPr>
-          <p:cNvPr id="12" name="Rounded Rectangle 11"/>
+          <p:cNvPr id="13" name="Rounded Rectangle 12"/>
           <p:cNvSpPr/>
           <p:nvPr/>
         </p:nvSpPr>
@@ -17457,6 +17443,88 @@
                 </a:solidFill>
               </a:rPr>
               <a:t>Why 3: 間接原因</a:t>
+            </a:r>
+          </a:p>
+        </p:txBody>
+      </p:sp>
+      <p:sp>
+        <p:nvSpPr>
+          <p:cNvPr id="14" name="TextBox 13"/>
+          <p:cNvSpPr txBox="1"/>
+          <p:nvPr/>
+        </p:nvSpPr>
+        <p:spPr>
+          <a:xfrm>
+            <a:off x="457200" y="1371600"/>
+            <a:ext cx="8229600" cy="5029200"/>
+          </a:xfrm>
+          <a:prstGeom prst="rect">
+            <a:avLst/>
+          </a:prstGeom>
+          <a:noFill/>
+        </p:spPr>
+        <p:txBody>
+          <a:bodyPr wrap="square" lIns="45720" rIns="45720" tIns="18288" bIns="18288"/>
+          <a:lstStyle/>
+          <a:p>
+            <a:pPr>
+              <a:defRPr b="1" sz="1800">
+                <a:solidFill>
+                  <a:srgbClr val="0070C0"/>
+                </a:solidFill>
+              </a:defRPr>
+            </a:pPr>
+            <a:r>
+              <a:t>為什麼需要 5-Why:</a:t>
+            </a:r>
+          </a:p>
+          <a:p>
+            <a:pPr>
+              <a:defRPr sz="1400"/>
+            </a:pPr>
+            <a:r>
+              <a:t>採用了排除法(移除TVS、移除IC)進行初步分析，邏輯尚屬合理，但缺乏更深層的物理分析(如SEM或X-ray)來確認IC內部的損傷機制。</a:t>
+            </a:r>
+          </a:p>
+          <a:p>
+            <a:pPr>
+              <a:defRPr sz="1400"/>
+            </a:pPr>
+            <a:r>
+              <a:t>結論僅停留在「推測」為I/O損傷，缺乏因果關係的深度分析。未說明為何會造成損傷(如ESD、過電壓或生產製程問題)，未應用5-Why分析。</a:t>
+            </a:r>
+          </a:p>
+          <a:p>
+            <a:br/>
+            <a:pPr>
+              <a:defRPr b="1"/>
+            </a:pPr>
+            <a:r>
+              <a:t>[推導流程]</a:t>
+            </a:r>
+          </a:p>
+          <a:p>
+            <a:pPr>
+              <a:defRPr sz="1200"/>
+            </a:pPr>
+            <a:r>
+              <a:t>• 設定 DVT 正常品 vs PVT 異常品之對照組</a:t>
+            </a:r>
+          </a:p>
+          <a:p>
+            <a:pPr>
+              <a:defRPr sz="1200"/>
+            </a:pPr>
+            <a:r>
+              <a:t>• 使用獨立樣本 t 檢定驗證參數顯著性 (p &lt; 0.05)</a:t>
+            </a:r>
+          </a:p>
+          <a:p>
+            <a:pPr>
+              <a:defRPr sz="1200"/>
+            </a:pPr>
+            <a:r>
+              <a:t>• 確保統計證據支持最終提到的根本原因</a:t>
             </a:r>
           </a:p>
         </p:txBody>

</xml_diff>